<commit_message>
feat(evaluacion): anadir infraestructura de evaluacion continua y pasaporte cifrado (PSLL)
</commit_message>
<xml_diff>
--- a/Temas EB/Sesiones EB/Sesion 03/Sesion 03 - Oferta, Demanda y Equilibrio en el Mercado de Trabajo.pptx
+++ b/Temas EB/Sesiones EB/Sesion 03/Sesion 03 - Oferta, Demanda y Equilibrio en el Mercado de Trabajo.pptx
@@ -20,7 +20,6 @@
     <p:sldId id="266" r:id="rId14"/>
     <p:sldId id="267" r:id="rId15"/>
     <p:sldId id="269" r:id="rId16"/>
-    <p:sldId id="268" r:id="rId17"/>
   </p:sldIdLst>
   <p:sldSz cx="12192000" cy="6858000"/>
   <p:notesSz cx="6858000" cy="9144000"/>
@@ -317,7 +316,7 @@
           <a:p>
             <a:fld id="{5BCAD085-E8A6-8845-BD4E-CB4CCA059FC4}" type="datetimeFigureOut">
               <a:rPr lang="en-US" smtClean="0"/>
-              <a:t>9/18/2026</a:t>
+              <a:t>9/20/2026</a:t>
             </a:fld>
             <a:endParaRPr lang="en-US"/>
           </a:p>
@@ -485,7 +484,7 @@
           <a:p>
             <a:fld id="{5BCAD085-E8A6-8845-BD4E-CB4CCA059FC4}" type="datetimeFigureOut">
               <a:rPr lang="en-US" smtClean="0"/>
-              <a:t>9/18/2026</a:t>
+              <a:t>9/20/2026</a:t>
             </a:fld>
             <a:endParaRPr lang="en-US"/>
           </a:p>
@@ -663,7 +662,7 @@
           <a:p>
             <a:fld id="{5BCAD085-E8A6-8845-BD4E-CB4CCA059FC4}" type="datetimeFigureOut">
               <a:rPr lang="en-US" smtClean="0"/>
-              <a:t>9/18/2026</a:t>
+              <a:t>9/20/2026</a:t>
             </a:fld>
             <a:endParaRPr lang="en-US"/>
           </a:p>
@@ -831,7 +830,7 @@
           <a:p>
             <a:fld id="{5BCAD085-E8A6-8845-BD4E-CB4CCA059FC4}" type="datetimeFigureOut">
               <a:rPr lang="en-US" smtClean="0"/>
-              <a:t>9/18/2026</a:t>
+              <a:t>9/20/2026</a:t>
             </a:fld>
             <a:endParaRPr lang="en-US"/>
           </a:p>
@@ -1076,7 +1075,7 @@
           <a:p>
             <a:fld id="{5BCAD085-E8A6-8845-BD4E-CB4CCA059FC4}" type="datetimeFigureOut">
               <a:rPr lang="en-US" smtClean="0"/>
-              <a:t>9/18/2026</a:t>
+              <a:t>9/20/2026</a:t>
             </a:fld>
             <a:endParaRPr lang="en-US"/>
           </a:p>
@@ -1361,7 +1360,7 @@
           <a:p>
             <a:fld id="{5BCAD085-E8A6-8845-BD4E-CB4CCA059FC4}" type="datetimeFigureOut">
               <a:rPr lang="en-US" smtClean="0"/>
-              <a:t>9/18/2026</a:t>
+              <a:t>9/20/2026</a:t>
             </a:fld>
             <a:endParaRPr lang="en-US"/>
           </a:p>
@@ -1780,7 +1779,7 @@
           <a:p>
             <a:fld id="{5BCAD085-E8A6-8845-BD4E-CB4CCA059FC4}" type="datetimeFigureOut">
               <a:rPr lang="en-US" smtClean="0"/>
-              <a:t>9/18/2026</a:t>
+              <a:t>9/20/2026</a:t>
             </a:fld>
             <a:endParaRPr lang="en-US"/>
           </a:p>
@@ -1897,7 +1896,7 @@
           <a:p>
             <a:fld id="{5BCAD085-E8A6-8845-BD4E-CB4CCA059FC4}" type="datetimeFigureOut">
               <a:rPr lang="en-US" smtClean="0"/>
-              <a:t>9/18/2026</a:t>
+              <a:t>9/20/2026</a:t>
             </a:fld>
             <a:endParaRPr lang="en-US"/>
           </a:p>
@@ -1992,7 +1991,7 @@
           <a:p>
             <a:fld id="{5BCAD085-E8A6-8845-BD4E-CB4CCA059FC4}" type="datetimeFigureOut">
               <a:rPr lang="en-US" smtClean="0"/>
-              <a:t>9/18/2026</a:t>
+              <a:t>9/20/2026</a:t>
             </a:fld>
             <a:endParaRPr lang="en-US"/>
           </a:p>
@@ -2267,7 +2266,7 @@
           <a:p>
             <a:fld id="{5BCAD085-E8A6-8845-BD4E-CB4CCA059FC4}" type="datetimeFigureOut">
               <a:rPr lang="en-US" smtClean="0"/>
-              <a:t>9/18/2026</a:t>
+              <a:t>9/20/2026</a:t>
             </a:fld>
             <a:endParaRPr lang="en-US"/>
           </a:p>
@@ -2519,7 +2518,7 @@
           <a:p>
             <a:fld id="{5BCAD085-E8A6-8845-BD4E-CB4CCA059FC4}" type="datetimeFigureOut">
               <a:rPr lang="en-US" smtClean="0"/>
-              <a:t>9/18/2026</a:t>
+              <a:t>9/20/2026</a:t>
             </a:fld>
             <a:endParaRPr lang="en-US"/>
           </a:p>
@@ -2730,7 +2729,7 @@
           <a:p>
             <a:fld id="{5BCAD085-E8A6-8845-BD4E-CB4CCA059FC4}" type="datetimeFigureOut">
               <a:rPr lang="en-US" smtClean="0"/>
-              <a:t>9/18/2026</a:t>
+              <a:t>9/20/2026</a:t>
             </a:fld>
             <a:endParaRPr lang="en-US"/>
           </a:p>
@@ -6081,91 +6080,576 @@
           </a:p>
         </p:txBody>
       </p:sp>
-      <p:sp>
-        <p:nvSpPr>
-          <p:cNvPr id="8" name="Rounded Rectangle 7"/>
-          <p:cNvSpPr/>
-          <p:nvPr/>
-        </p:nvSpPr>
-        <p:spPr>
-          <a:xfrm>
-            <a:off x="548640" y="1645920"/>
-            <a:ext cx="11064240" cy="4389120"/>
-          </a:xfrm>
-          <a:prstGeom prst="roundRect">
-            <a:avLst/>
-          </a:prstGeom>
-          <a:solidFill>
-            <a:srgbClr val="F4F8F5"/>
-          </a:solidFill>
-          <a:ln>
-            <a:solidFill>
-              <a:srgbClr val="E98F71"/>
-            </a:solidFill>
-          </a:ln>
-        </p:spPr>
-        <p:style>
-          <a:lnRef idx="1">
-            <a:schemeClr val="accent1"/>
-          </a:lnRef>
-          <a:fillRef idx="3">
-            <a:schemeClr val="accent1"/>
-          </a:fillRef>
-          <a:effectRef idx="2">
-            <a:schemeClr val="accent1"/>
-          </a:effectRef>
-          <a:fontRef idx="minor">
-            <a:schemeClr val="lt1"/>
-          </a:fontRef>
-        </p:style>
-        <p:txBody>
-          <a:bodyPr wrap="square" rtlCol="0" anchor="ctr"/>
-          <a:lstStyle/>
-          <a:p>
-            <a:pPr algn="ctr">
-              <a:defRPr sz="1500" b="1">
+      <mc:AlternateContent xmlns:mc="http://schemas.openxmlformats.org/markup-compatibility/2006">
+        <mc:Choice xmlns:a14="http://schemas.microsoft.com/office/drawing/2010/main" Requires="a14">
+          <p:sp>
+            <p:nvSpPr>
+              <p:cNvPr id="8" name="Rounded Rectangle 7"/>
+              <p:cNvSpPr/>
+              <p:nvPr/>
+            </p:nvSpPr>
+            <p:spPr>
+              <a:xfrm>
+                <a:off x="548640" y="1645920"/>
+                <a:ext cx="11064240" cy="4389120"/>
+              </a:xfrm>
+              <a:prstGeom prst="roundRect">
+                <a:avLst/>
+              </a:prstGeom>
+              <a:solidFill>
+                <a:srgbClr val="F4F8F5"/>
+              </a:solidFill>
+              <a:ln>
                 <a:solidFill>
                   <a:srgbClr val="E98F71"/>
                 </a:solidFill>
-                <a:latin typeface="Outfit"/>
-              </a:defRPr>
-            </a:pPr>
-            <a:r>
-              <a:t>CASO PRÁCTICO TIPO EXAMEN (10 MINUTOS)</a:t>
-            </a:r>
-          </a:p>
-          <a:p>
-            <a:pPr>
-              <a:defRPr sz="1500">
-                <a:solidFill>
-                  <a:srgbClr val="2F3A30"/>
-                </a:solidFill>
-                <a:latin typeface="Calibri"/>
-              </a:defRPr>
-            </a:pPr>
-            <a:r>
-              <a:t>«Un trabajador desempleado percibe un subsidio asistencial de 480 €/mes (Y_NS). Recibe una oferta para trabajar como operario de logística a jornada completa por 1.150 € netos mensuales. Para acudir al puesto debe gastar 180 € al mes en combustible y perdería de forma inmediata la ayuda de 480 €.</a:t>
-            </a:r>
-            <a:br/>
-            <a:br/>
-            <a:r>
-              <a:t>Responda en papel de su puño y letra:</a:t>
-            </a:r>
-            <a:br/>
-            <a:r>
-              <a:t>a) Calcule la ganancia neta real por hora trabajada de este operario.</a:t>
-            </a:r>
-            <a:br/>
-            <a:r>
-              <a:t>b) Explique analíticamente por qué el salario ofertado se sitúa por debajo de su Salario de Reserva (wR).</a:t>
-            </a:r>
-            <a:br/>
-            <a:r>
-              <a:t>c) Proponga una medida técnica de política sociolaboral para corregir esta rigidez sin desamparar al desempleado.»</a:t>
-            </a:r>
-          </a:p>
-        </p:txBody>
-      </p:sp>
+              </a:ln>
+            </p:spPr>
+            <p:style>
+              <a:lnRef idx="1">
+                <a:schemeClr val="accent1"/>
+              </a:lnRef>
+              <a:fillRef idx="3">
+                <a:schemeClr val="accent1"/>
+              </a:fillRef>
+              <a:effectRef idx="2">
+                <a:schemeClr val="accent1"/>
+              </a:effectRef>
+              <a:fontRef idx="minor">
+                <a:schemeClr val="lt1"/>
+              </a:fontRef>
+            </p:style>
+            <p:txBody>
+              <a:bodyPr wrap="square" rtlCol="0" anchor="ctr"/>
+              <a:lstStyle/>
+              <a:p>
+                <a:pPr algn="ctr">
+                  <a:defRPr sz="1500" b="1">
+                    <a:solidFill>
+                      <a:srgbClr val="E98F71"/>
+                    </a:solidFill>
+                    <a:latin typeface="Outfit"/>
+                  </a:defRPr>
+                </a:pPr>
+                <a:r>
+                  <a:rPr dirty="0"/>
+                  <a:t>CASO PRÁCTICO TIPO EXAMEN (10 MINUTOS)</a:t>
+                </a:r>
+              </a:p>
+              <a:p>
+                <a:pPr>
+                  <a:defRPr sz="1500">
+                    <a:solidFill>
+                      <a:srgbClr val="2F3A30"/>
+                    </a:solidFill>
+                    <a:latin typeface="Calibri"/>
+                  </a:defRPr>
+                </a:pPr>
+                <a:r>
+                  <a:rPr dirty="0"/>
+                  <a:t>«Un </a:t>
+                </a:r>
+                <a:r>
+                  <a:rPr dirty="0" err="1"/>
+                  <a:t>trabajador</a:t>
+                </a:r>
+                <a:r>
+                  <a:rPr dirty="0"/>
+                  <a:t> </a:t>
+                </a:r>
+                <a:r>
+                  <a:rPr dirty="0" err="1"/>
+                  <a:t>desempleado</a:t>
+                </a:r>
+                <a:r>
+                  <a:rPr dirty="0"/>
+                  <a:t> </a:t>
+                </a:r>
+                <a:r>
+                  <a:rPr dirty="0" err="1"/>
+                  <a:t>percibe</a:t>
+                </a:r>
+                <a:r>
+                  <a:rPr dirty="0"/>
+                  <a:t> un </a:t>
+                </a:r>
+                <a:r>
+                  <a:rPr dirty="0" err="1"/>
+                  <a:t>subsidio</a:t>
+                </a:r>
+                <a:r>
+                  <a:rPr dirty="0"/>
+                  <a:t> </a:t>
+                </a:r>
+                <a:r>
+                  <a:rPr dirty="0" err="1"/>
+                  <a:t>asistencial</a:t>
+                </a:r>
+                <a:r>
+                  <a:rPr dirty="0"/>
+                  <a:t> de 480 €/</a:t>
+                </a:r>
+                <a:r>
+                  <a:rPr dirty="0" err="1"/>
+                  <a:t>mes</a:t>
+                </a:r>
+                <a:r>
+                  <a:rPr dirty="0"/>
+                  <a:t> (</a:t>
+                </a:r>
+                <a14:m>
+                  <m:oMath xmlns:m="http://schemas.openxmlformats.org/officeDocument/2006/math">
+                    <m:sSub>
+                      <m:sSubPr>
+                        <m:ctrlPr>
+                          <a:rPr lang="es-ES" i="1" dirty="0" smtClean="0">
+                            <a:latin typeface="Cambria Math" panose="02040503050406030204" pitchFamily="18" charset="0"/>
+                          </a:rPr>
+                        </m:ctrlPr>
+                      </m:sSubPr>
+                      <m:e>
+                        <m:r>
+                          <a:rPr lang="es-ES" i="1" dirty="0" smtClean="0">
+                            <a:latin typeface="Cambria Math" panose="02040503050406030204" pitchFamily="18" charset="0"/>
+                          </a:rPr>
+                          <m:t>𝑌</m:t>
+                        </m:r>
+                      </m:e>
+                      <m:sub>
+                        <m:r>
+                          <a:rPr lang="es-ES" i="1" dirty="0" smtClean="0">
+                            <a:latin typeface="Cambria Math" panose="02040503050406030204" pitchFamily="18" charset="0"/>
+                          </a:rPr>
+                          <m:t>𝑁𝑆</m:t>
+                        </m:r>
+                      </m:sub>
+                    </m:sSub>
+                  </m:oMath>
+                </a14:m>
+                <a:r>
+                  <a:rPr dirty="0"/>
+                  <a:t>). </a:t>
+                </a:r>
+                <a:r>
+                  <a:rPr dirty="0" err="1"/>
+                  <a:t>Recibe</a:t>
+                </a:r>
+                <a:r>
+                  <a:rPr dirty="0"/>
+                  <a:t> </a:t>
+                </a:r>
+                <a:r>
+                  <a:rPr dirty="0" err="1"/>
+                  <a:t>una</a:t>
+                </a:r>
+                <a:r>
+                  <a:rPr dirty="0"/>
+                  <a:t> </a:t>
+                </a:r>
+                <a:r>
+                  <a:rPr dirty="0" err="1"/>
+                  <a:t>oferta</a:t>
+                </a:r>
+                <a:r>
+                  <a:rPr dirty="0"/>
+                  <a:t> para </a:t>
+                </a:r>
+                <a:r>
+                  <a:rPr dirty="0" err="1"/>
+                  <a:t>trabajar</a:t>
+                </a:r>
+                <a:r>
+                  <a:rPr dirty="0"/>
+                  <a:t> </a:t>
+                </a:r>
+                <a:r>
+                  <a:rPr dirty="0" err="1"/>
+                  <a:t>como</a:t>
+                </a:r>
+                <a:r>
+                  <a:rPr dirty="0"/>
+                  <a:t> </a:t>
+                </a:r>
+                <a:r>
+                  <a:rPr dirty="0" err="1"/>
+                  <a:t>operario</a:t>
+                </a:r>
+                <a:r>
+                  <a:rPr dirty="0"/>
+                  <a:t> de </a:t>
+                </a:r>
+                <a:r>
+                  <a:rPr dirty="0" err="1"/>
+                  <a:t>logística</a:t>
+                </a:r>
+                <a:r>
+                  <a:rPr dirty="0"/>
+                  <a:t> a jornada completa </a:t>
+                </a:r>
+                <a:r>
+                  <a:rPr dirty="0" err="1"/>
+                  <a:t>por</a:t>
+                </a:r>
+                <a:r>
+                  <a:rPr dirty="0"/>
+                  <a:t> 1.150 € </a:t>
+                </a:r>
+                <a:r>
+                  <a:rPr dirty="0" err="1"/>
+                  <a:t>netos</a:t>
+                </a:r>
+                <a:r>
+                  <a:rPr dirty="0"/>
+                  <a:t> </a:t>
+                </a:r>
+                <a:r>
+                  <a:rPr dirty="0" err="1"/>
+                  <a:t>mensuales</a:t>
+                </a:r>
+                <a:r>
+                  <a:rPr dirty="0"/>
+                  <a:t>. Para </a:t>
+                </a:r>
+                <a:r>
+                  <a:rPr dirty="0" err="1"/>
+                  <a:t>acudir</a:t>
+                </a:r>
+                <a:r>
+                  <a:rPr dirty="0"/>
+                  <a:t> al </a:t>
+                </a:r>
+                <a:r>
+                  <a:rPr dirty="0" err="1"/>
+                  <a:t>puesto</a:t>
+                </a:r>
+                <a:r>
+                  <a:rPr dirty="0"/>
+                  <a:t> </a:t>
+                </a:r>
+                <a:r>
+                  <a:rPr dirty="0" err="1"/>
+                  <a:t>debe</a:t>
+                </a:r>
+                <a:r>
+                  <a:rPr dirty="0"/>
+                  <a:t> </a:t>
+                </a:r>
+                <a:r>
+                  <a:rPr dirty="0" err="1"/>
+                  <a:t>gastar</a:t>
+                </a:r>
+                <a:r>
+                  <a:rPr dirty="0"/>
+                  <a:t> 180 € al </a:t>
+                </a:r>
+                <a:r>
+                  <a:rPr dirty="0" err="1"/>
+                  <a:t>mes</a:t>
+                </a:r>
+                <a:r>
+                  <a:rPr dirty="0"/>
+                  <a:t> </a:t>
+                </a:r>
+                <a:r>
+                  <a:rPr dirty="0" err="1"/>
+                  <a:t>en</a:t>
+                </a:r>
+                <a:r>
+                  <a:rPr dirty="0"/>
+                  <a:t> combustible y </a:t>
+                </a:r>
+                <a:r>
+                  <a:rPr dirty="0" err="1"/>
+                  <a:t>perdería</a:t>
+                </a:r>
+                <a:r>
+                  <a:rPr dirty="0"/>
+                  <a:t> de forma </a:t>
+                </a:r>
+                <a:r>
+                  <a:rPr dirty="0" err="1"/>
+                  <a:t>inmediata</a:t>
+                </a:r>
+                <a:r>
+                  <a:rPr dirty="0"/>
+                  <a:t> la </a:t>
+                </a:r>
+                <a:r>
+                  <a:rPr dirty="0" err="1"/>
+                  <a:t>ayuda</a:t>
+                </a:r>
+                <a:r>
+                  <a:rPr dirty="0"/>
+                  <a:t> de 480 €.</a:t>
+                </a:r>
+                <a:br>
+                  <a:rPr dirty="0"/>
+                </a:br>
+                <a:br>
+                  <a:rPr dirty="0"/>
+                </a:br>
+                <a:r>
+                  <a:rPr dirty="0" err="1"/>
+                  <a:t>Responda</a:t>
+                </a:r>
+                <a:r>
+                  <a:rPr dirty="0"/>
+                  <a:t> </a:t>
+                </a:r>
+                <a:r>
+                  <a:rPr dirty="0" err="1"/>
+                  <a:t>en</a:t>
+                </a:r>
+                <a:r>
+                  <a:rPr dirty="0"/>
+                  <a:t> </a:t>
+                </a:r>
+                <a:r>
+                  <a:rPr dirty="0" err="1"/>
+                  <a:t>papel</a:t>
+                </a:r>
+                <a:r>
+                  <a:rPr dirty="0"/>
+                  <a:t> de </a:t>
+                </a:r>
+                <a:r>
+                  <a:rPr dirty="0" err="1"/>
+                  <a:t>su</a:t>
+                </a:r>
+                <a:r>
+                  <a:rPr dirty="0"/>
+                  <a:t> </a:t>
+                </a:r>
+                <a:r>
+                  <a:rPr dirty="0" err="1"/>
+                  <a:t>puño</a:t>
+                </a:r>
+                <a:r>
+                  <a:rPr dirty="0"/>
+                  <a:t> y </a:t>
+                </a:r>
+                <a:r>
+                  <a:rPr dirty="0" err="1"/>
+                  <a:t>letra</a:t>
+                </a:r>
+                <a:r>
+                  <a:rPr dirty="0"/>
+                  <a:t>:</a:t>
+                </a:r>
+                <a:br>
+                  <a:rPr dirty="0"/>
+                </a:br>
+                <a:r>
+                  <a:rPr dirty="0"/>
+                  <a:t>a) </a:t>
+                </a:r>
+                <a:r>
+                  <a:rPr dirty="0" err="1"/>
+                  <a:t>Calcule</a:t>
+                </a:r>
+                <a:r>
+                  <a:rPr dirty="0"/>
+                  <a:t> la </a:t>
+                </a:r>
+                <a:r>
+                  <a:rPr dirty="0" err="1"/>
+                  <a:t>ganancia</a:t>
+                </a:r>
+                <a:r>
+                  <a:rPr dirty="0"/>
+                  <a:t> </a:t>
+                </a:r>
+                <a:r>
+                  <a:rPr dirty="0" err="1"/>
+                  <a:t>neta</a:t>
+                </a:r>
+                <a:r>
+                  <a:rPr dirty="0"/>
+                  <a:t> real </a:t>
+                </a:r>
+                <a:r>
+                  <a:rPr dirty="0" err="1"/>
+                  <a:t>por</a:t>
+                </a:r>
+                <a:r>
+                  <a:rPr dirty="0"/>
+                  <a:t> hora </a:t>
+                </a:r>
+                <a:r>
+                  <a:rPr dirty="0" err="1"/>
+                  <a:t>trabajada</a:t>
+                </a:r>
+                <a:r>
+                  <a:rPr dirty="0"/>
+                  <a:t> de </a:t>
+                </a:r>
+                <a:r>
+                  <a:rPr dirty="0" err="1"/>
+                  <a:t>este</a:t>
+                </a:r>
+                <a:r>
+                  <a:rPr dirty="0"/>
+                  <a:t> </a:t>
+                </a:r>
+                <a:r>
+                  <a:rPr dirty="0" err="1"/>
+                  <a:t>operario</a:t>
+                </a:r>
+                <a:r>
+                  <a:rPr dirty="0"/>
+                  <a:t>.</a:t>
+                </a:r>
+                <a:br>
+                  <a:rPr dirty="0"/>
+                </a:br>
+                <a:r>
+                  <a:rPr dirty="0"/>
+                  <a:t>b) </a:t>
+                </a:r>
+                <a:r>
+                  <a:rPr dirty="0" err="1"/>
+                  <a:t>Explique</a:t>
+                </a:r>
+                <a:r>
+                  <a:rPr dirty="0"/>
+                  <a:t> </a:t>
+                </a:r>
+                <a:r>
+                  <a:rPr dirty="0" err="1"/>
+                  <a:t>analíticamente</a:t>
+                </a:r>
+                <a:r>
+                  <a:rPr dirty="0"/>
+                  <a:t> </a:t>
+                </a:r>
+                <a:r>
+                  <a:rPr dirty="0" err="1"/>
+                  <a:t>por</a:t>
+                </a:r>
+                <a:r>
+                  <a:rPr dirty="0"/>
+                  <a:t> </a:t>
+                </a:r>
+                <a:r>
+                  <a:rPr dirty="0" err="1"/>
+                  <a:t>qué</a:t>
+                </a:r>
+                <a:r>
+                  <a:rPr dirty="0"/>
+                  <a:t> el </a:t>
+                </a:r>
+                <a:r>
+                  <a:rPr dirty="0" err="1"/>
+                  <a:t>salario</a:t>
+                </a:r>
+                <a:r>
+                  <a:rPr dirty="0"/>
+                  <a:t> </a:t>
+                </a:r>
+                <a:r>
+                  <a:rPr dirty="0" err="1"/>
+                  <a:t>ofertado</a:t>
+                </a:r>
+                <a:r>
+                  <a:rPr dirty="0"/>
+                  <a:t> se </a:t>
+                </a:r>
+                <a:r>
+                  <a:rPr dirty="0" err="1"/>
+                  <a:t>sitúa</a:t>
+                </a:r>
+                <a:r>
+                  <a:rPr dirty="0"/>
+                  <a:t> </a:t>
+                </a:r>
+                <a:r>
+                  <a:rPr dirty="0" err="1"/>
+                  <a:t>por</a:t>
+                </a:r>
+                <a:r>
+                  <a:rPr dirty="0"/>
+                  <a:t> </a:t>
+                </a:r>
+                <a:r>
+                  <a:rPr dirty="0" err="1"/>
+                  <a:t>debajo</a:t>
+                </a:r>
+                <a:r>
+                  <a:rPr dirty="0"/>
+                  <a:t> de </a:t>
+                </a:r>
+                <a:r>
+                  <a:rPr dirty="0" err="1"/>
+                  <a:t>su</a:t>
+                </a:r>
+                <a:r>
+                  <a:rPr dirty="0"/>
+                  <a:t> Salario de </a:t>
+                </a:r>
+                <a:r>
+                  <a:rPr dirty="0" err="1"/>
+                  <a:t>Reserva</a:t>
+                </a:r>
+                <a:r>
+                  <a:rPr dirty="0"/>
+                  <a:t> (</a:t>
+                </a:r>
+                <a:r>
+                  <a:rPr dirty="0" err="1"/>
+                  <a:t>wR</a:t>
+                </a:r>
+                <a:r>
+                  <a:rPr dirty="0"/>
+                  <a:t>).</a:t>
+                </a:r>
+              </a:p>
+            </p:txBody>
+          </p:sp>
+        </mc:Choice>
+        <mc:Fallback>
+          <p:sp>
+            <p:nvSpPr>
+              <p:cNvPr id="8" name="Rounded Rectangle 7"/>
+              <p:cNvSpPr>
+                <a:spLocks noRot="1" noChangeAspect="1" noMove="1" noResize="1" noEditPoints="1" noAdjustHandles="1" noChangeArrowheads="1" noChangeShapeType="1" noTextEdit="1"/>
+              </p:cNvSpPr>
+              <p:nvPr/>
+            </p:nvSpPr>
+            <p:spPr>
+              <a:xfrm>
+                <a:off x="548640" y="1645920"/>
+                <a:ext cx="11064240" cy="4389120"/>
+              </a:xfrm>
+              <a:prstGeom prst="roundRect">
+                <a:avLst/>
+              </a:prstGeom>
+              <a:blipFill>
+                <a:blip r:embed="rId3"/>
+                <a:stretch>
+                  <a:fillRect/>
+                </a:stretch>
+              </a:blipFill>
+              <a:ln>
+                <a:solidFill>
+                  <a:srgbClr val="E98F71"/>
+                </a:solidFill>
+              </a:ln>
+            </p:spPr>
+            <p:txBody>
+              <a:bodyPr/>
+              <a:lstStyle/>
+              <a:p>
+                <a:r>
+                  <a:rPr lang="es-ES">
+                    <a:noFill/>
+                  </a:rPr>
+                  <a:t> </a:t>
+                </a:r>
+              </a:p>
+            </p:txBody>
+          </p:sp>
+        </mc:Fallback>
+      </mc:AlternateContent>
     </p:spTree>
   </p:cSld>
   <p:clrMapOvr>
@@ -6294,8 +6778,50 @@
               </a:defRPr>
             </a:pPr>
             <a:r>
-              <a:t>Fotografía y subida instantánea mediante código QR institucional</a:t>
-            </a:r>
+              <a:rPr dirty="0" err="1"/>
+              <a:t>Fotografía</a:t>
+            </a:r>
+            <a:r>
+              <a:rPr dirty="0"/>
+              <a:t> y </a:t>
+            </a:r>
+            <a:r>
+              <a:rPr dirty="0" err="1"/>
+              <a:t>subida</a:t>
+            </a:r>
+            <a:r>
+              <a:rPr dirty="0"/>
+              <a:t> </a:t>
+            </a:r>
+            <a:r>
+              <a:rPr dirty="0" err="1"/>
+              <a:t>instantánea</a:t>
+            </a:r>
+            <a:r>
+              <a:rPr dirty="0"/>
+              <a:t> </a:t>
+            </a:r>
+            <a:r>
+              <a:rPr dirty="0" err="1"/>
+              <a:t>mediante</a:t>
+            </a:r>
+            <a:r>
+              <a:rPr dirty="0"/>
+              <a:t> </a:t>
+            </a:r>
+            <a:r>
+              <a:rPr dirty="0" err="1"/>
+              <a:t>código</a:t>
+            </a:r>
+            <a:r>
+              <a:rPr dirty="0"/>
+              <a:t> QR </a:t>
+            </a:r>
+            <a:r>
+              <a:rPr dirty="0" err="1"/>
+              <a:t>institucional</a:t>
+            </a:r>
+            <a:endParaRPr dirty="0"/>
           </a:p>
         </p:txBody>
       </p:sp>
@@ -6495,7 +7021,7 @@
         <p:spPr>
           <a:xfrm>
             <a:off x="7772400" y="1645920"/>
-            <a:ext cx="3840480" cy="4389120"/>
+            <a:ext cx="3840480" cy="1411912"/>
           </a:xfrm>
           <a:prstGeom prst="roundRect">
             <a:avLst/>
@@ -6556,6 +7082,36 @@
           </a:p>
         </p:txBody>
       </p:sp>
+      <p:pic>
+        <p:nvPicPr>
+          <p:cNvPr id="10" name="Imagen 9" descr="Código QR">
+            <a:extLst>
+              <a:ext uri="{FF2B5EF4-FFF2-40B4-BE49-F238E27FC236}">
+                <a16:creationId xmlns:a16="http://schemas.microsoft.com/office/drawing/2014/main" id="{D7F7282D-3D3A-4588-F89E-7BF9C5BC74B3}"/>
+              </a:ext>
+            </a:extLst>
+          </p:cNvPr>
+          <p:cNvPicPr>
+            <a:picLocks noChangeAspect="1"/>
+          </p:cNvPicPr>
+          <p:nvPr/>
+        </p:nvPicPr>
+        <p:blipFill>
+          <a:blip r:embed="rId3"/>
+          <a:stretch>
+            <a:fillRect/>
+          </a:stretch>
+        </p:blipFill>
+        <p:spPr>
+          <a:xfrm>
+            <a:off x="7907593" y="3108960"/>
+            <a:ext cx="3429000" cy="3429000"/>
+          </a:xfrm>
+          <a:prstGeom prst="rect">
+            <a:avLst/>
+          </a:prstGeom>
+        </p:spPr>
+      </p:pic>
     </p:spTree>
   </p:cSld>
   <p:clrMapOvr>
@@ -6891,418 +7447,6 @@
 </p:sld>
 </file>
 
-<file path=ppt/slides/slide16.xml><?xml version="1.0" encoding="utf-8"?>
-<p:sld xmlns:a="http://schemas.openxmlformats.org/drawingml/2006/main" xmlns:r="http://schemas.openxmlformats.org/officeDocument/2006/relationships" xmlns:p="http://schemas.openxmlformats.org/presentationml/2006/main">
-  <p:cSld>
-    <p:spTree>
-      <p:nvGrpSpPr>
-        <p:cNvPr id="1" name=""/>
-        <p:cNvGrpSpPr/>
-        <p:nvPr/>
-      </p:nvGrpSpPr>
-      <p:grpSpPr>
-        <a:xfrm>
-          <a:off x="0" y="0"/>
-          <a:ext cx="0" cy="0"/>
-          <a:chOff x="0" y="0"/>
-          <a:chExt cx="0" cy="0"/>
-        </a:xfrm>
-      </p:grpSpPr>
-      <p:sp>
-        <p:nvSpPr>
-          <p:cNvPr id="2" name="TextBox 1"/>
-          <p:cNvSpPr txBox="1"/>
-          <p:nvPr/>
-        </p:nvSpPr>
-        <p:spPr>
-          <a:xfrm>
-            <a:off x="548640" y="365760"/>
-            <a:ext cx="9144000" cy="274320"/>
-          </a:xfrm>
-          <a:prstGeom prst="rect">
-            <a:avLst/>
-          </a:prstGeom>
-          <a:noFill/>
-        </p:spPr>
-        <p:txBody>
-          <a:bodyPr wrap="none">
-            <a:spAutoFit/>
-          </a:bodyPr>
-          <a:lstStyle/>
-          <a:p>
-            <a:pPr>
-              <a:defRPr sz="1100" b="1">
-                <a:solidFill>
-                  <a:srgbClr val="76927A"/>
-                </a:solidFill>
-                <a:latin typeface="Calibri"/>
-              </a:defRPr>
-            </a:pPr>
-            <a:r>
-              <a:t>BLOQUE 5 · CORRECCIÓN INMEDIATA (5 MIN)</a:t>
-            </a:r>
-          </a:p>
-        </p:txBody>
-      </p:sp>
-      <p:sp>
-        <p:nvSpPr>
-          <p:cNvPr id="3" name="TextBox 2"/>
-          <p:cNvSpPr txBox="1"/>
-          <p:nvPr/>
-        </p:nvSpPr>
-        <p:spPr>
-          <a:xfrm>
-            <a:off x="548640" y="640080"/>
-            <a:ext cx="9601200" cy="457200"/>
-          </a:xfrm>
-          <a:prstGeom prst="rect">
-            <a:avLst/>
-          </a:prstGeom>
-          <a:noFill/>
-        </p:spPr>
-        <p:txBody>
-          <a:bodyPr wrap="none">
-            <a:spAutoFit/>
-          </a:bodyPr>
-          <a:lstStyle/>
-          <a:p>
-            <a:pPr>
-              <a:defRPr sz="2000" b="1">
-                <a:solidFill>
-                  <a:srgbClr val="113927"/>
-                </a:solidFill>
-                <a:latin typeface="Outfit"/>
-              </a:defRPr>
-            </a:pPr>
-            <a:r>
-              <a:t>Solución Modelo y Rúbrica Oficial de Evaluación</a:t>
-            </a:r>
-          </a:p>
-        </p:txBody>
-      </p:sp>
-      <p:sp>
-        <p:nvSpPr>
-          <p:cNvPr id="4" name="TextBox 3"/>
-          <p:cNvSpPr txBox="1"/>
-          <p:nvPr/>
-        </p:nvSpPr>
-        <p:spPr>
-          <a:xfrm>
-            <a:off x="548640" y="1097280"/>
-            <a:ext cx="9601200" cy="365760"/>
-          </a:xfrm>
-          <a:prstGeom prst="rect">
-            <a:avLst/>
-          </a:prstGeom>
-          <a:noFill/>
-        </p:spPr>
-        <p:txBody>
-          <a:bodyPr wrap="none">
-            <a:spAutoFit/>
-          </a:bodyPr>
-          <a:lstStyle/>
-          <a:p>
-            <a:pPr>
-              <a:defRPr sz="1200">
-                <a:solidFill>
-                  <a:srgbClr val="76927A"/>
-                </a:solidFill>
-                <a:latin typeface="Calibri"/>
-              </a:defRPr>
-            </a:pPr>
-            <a:r>
-              <a:t>Feedback formativo para la autocorrección del reto</a:t>
-            </a:r>
-          </a:p>
-        </p:txBody>
-      </p:sp>
-      <p:pic>
-        <p:nvPicPr>
-          <p:cNvPr id="5" name="Picture 4" descr="psll_lockup.png"/>
-          <p:cNvPicPr>
-            <a:picLocks noChangeAspect="1"/>
-          </p:cNvPicPr>
-          <p:nvPr/>
-        </p:nvPicPr>
-        <p:blipFill>
-          <a:blip r:embed="rId2"/>
-          <a:stretch>
-            <a:fillRect/>
-          </a:stretch>
-        </p:blipFill>
-        <p:spPr>
-          <a:xfrm>
-            <a:off x="10515600" y="365760"/>
-            <a:ext cx="1158544" cy="365760"/>
-          </a:xfrm>
-          <a:prstGeom prst="rect">
-            <a:avLst/>
-          </a:prstGeom>
-        </p:spPr>
-      </p:pic>
-      <p:sp>
-        <p:nvSpPr>
-          <p:cNvPr id="6" name="TextBox 5"/>
-          <p:cNvSpPr txBox="1"/>
-          <p:nvPr/>
-        </p:nvSpPr>
-        <p:spPr>
-          <a:xfrm>
-            <a:off x="548640" y="6400800"/>
-            <a:ext cx="9144000" cy="274320"/>
-          </a:xfrm>
-          <a:prstGeom prst="rect">
-            <a:avLst/>
-          </a:prstGeom>
-          <a:noFill/>
-        </p:spPr>
-        <p:txBody>
-          <a:bodyPr wrap="none">
-            <a:spAutoFit/>
-          </a:bodyPr>
-          <a:lstStyle/>
-          <a:p>
-            <a:pPr>
-              <a:defRPr sz="900">
-                <a:solidFill>
-                  <a:srgbClr val="76927A"/>
-                </a:solidFill>
-              </a:defRPr>
-            </a:pPr>
-            <a:r>
-              <a:t>Políticas Sociolaborales y de Empleo · Grado en RRLL y RRHH / Derecho · UPO</a:t>
-            </a:r>
-          </a:p>
-        </p:txBody>
-      </p:sp>
-      <p:sp>
-        <p:nvSpPr>
-          <p:cNvPr id="7" name="TextBox 6"/>
-          <p:cNvSpPr txBox="1"/>
-          <p:nvPr/>
-        </p:nvSpPr>
-        <p:spPr>
-          <a:xfrm>
-            <a:off x="10515600" y="6400800"/>
-            <a:ext cx="1097280" cy="274320"/>
-          </a:xfrm>
-          <a:prstGeom prst="rect">
-            <a:avLst/>
-          </a:prstGeom>
-          <a:noFill/>
-        </p:spPr>
-        <p:txBody>
-          <a:bodyPr wrap="none">
-            <a:spAutoFit/>
-          </a:bodyPr>
-          <a:lstStyle/>
-          <a:p>
-            <a:pPr algn="r">
-              <a:defRPr sz="900">
-                <a:solidFill>
-                  <a:srgbClr val="76927A"/>
-                </a:solidFill>
-                <a:latin typeface="Calibri"/>
-              </a:defRPr>
-            </a:pPr>
-            <a:r>
-              <a:t>15 / 16</a:t>
-            </a:r>
-          </a:p>
-        </p:txBody>
-      </p:sp>
-      <p:sp>
-        <p:nvSpPr>
-          <p:cNvPr id="8" name="Rounded Rectangle 7"/>
-          <p:cNvSpPr/>
-          <p:nvPr/>
-        </p:nvSpPr>
-        <p:spPr>
-          <a:xfrm>
-            <a:off x="548640" y="1645920"/>
-            <a:ext cx="5303520" cy="4389120"/>
-          </a:xfrm>
-          <a:prstGeom prst="roundRect">
-            <a:avLst/>
-          </a:prstGeom>
-          <a:solidFill>
-            <a:srgbClr val="F4F8F5"/>
-          </a:solidFill>
-          <a:ln>
-            <a:solidFill>
-              <a:srgbClr val="76927A"/>
-            </a:solidFill>
-          </a:ln>
-        </p:spPr>
-        <p:style>
-          <a:lnRef idx="1">
-            <a:schemeClr val="accent1"/>
-          </a:lnRef>
-          <a:fillRef idx="3">
-            <a:schemeClr val="accent1"/>
-          </a:fillRef>
-          <a:effectRef idx="2">
-            <a:schemeClr val="accent1"/>
-          </a:effectRef>
-          <a:fontRef idx="minor">
-            <a:schemeClr val="lt1"/>
-          </a:fontRef>
-        </p:style>
-        <p:txBody>
-          <a:bodyPr wrap="square" rtlCol="0" anchor="ctr"/>
-          <a:lstStyle/>
-          <a:p>
-            <a:pPr algn="ctr">
-              <a:defRPr sz="1400" b="1">
-                <a:solidFill>
-                  <a:srgbClr val="113927"/>
-                </a:solidFill>
-                <a:latin typeface="Outfit"/>
-              </a:defRPr>
-            </a:pPr>
-            <a:r>
-              <a:t>SOLUCIÓN MODELO</a:t>
-            </a:r>
-          </a:p>
-          <a:p>
-            <a:pPr>
-              <a:defRPr sz="1300">
-                <a:solidFill>
-                  <a:srgbClr val="2F3A30"/>
-                </a:solidFill>
-                <a:latin typeface="Calibri"/>
-              </a:defRPr>
-            </a:pPr>
-            <a:r>
-              <a:t>a) Ganancia Neta Real:</a:t>
-            </a:r>
-            <a:br/>
-            <a:r>
-              <a:t>   1.150 € - 480 € (subsidio perdido) - 180 € (transporte) = 490 €/mes netos adicionales.</a:t>
-            </a:r>
-            <a:br/>
-            <a:r>
-              <a:t>   Por 160h trabajadas -&gt; Ganancia real = 3,06 €/hora.</a:t>
-            </a:r>
-            <a:br/>
-            <a:br/>
-            <a:r>
-              <a:t>b) Justificación Analítica wR:</a:t>
-            </a:r>
-            <a:br/>
-            <a:r>
-              <a:t>   El operario valora su ocio y tiempo en &gt;3,06 €/h. Por tanto, w ofertado (3,06 €/h) &lt; wR, siendo racional rechazar la oferta.</a:t>
-            </a:r>
-            <a:br/>
-            <a:br/>
-            <a:r>
-              <a:t>c) Propuesta de Reforma:</a:t>
-            </a:r>
-            <a:br/>
-            <a:r>
-              <a:t>   Establecer una retirada progresiva del subsidio (METR &lt; 40%) o bonificar el transporte.</a:t>
-            </a:r>
-          </a:p>
-        </p:txBody>
-      </p:sp>
-      <p:sp>
-        <p:nvSpPr>
-          <p:cNvPr id="9" name="Rounded Rectangle 8"/>
-          <p:cNvSpPr/>
-          <p:nvPr/>
-        </p:nvSpPr>
-        <p:spPr>
-          <a:xfrm>
-            <a:off x="6217920" y="1645920"/>
-            <a:ext cx="5394960" cy="4389120"/>
-          </a:xfrm>
-          <a:prstGeom prst="roundRect">
-            <a:avLst/>
-          </a:prstGeom>
-          <a:solidFill>
-            <a:srgbClr val="FFFFFF"/>
-          </a:solidFill>
-          <a:ln>
-            <a:solidFill>
-              <a:srgbClr val="E98F71"/>
-            </a:solidFill>
-          </a:ln>
-        </p:spPr>
-        <p:style>
-          <a:lnRef idx="1">
-            <a:schemeClr val="accent1"/>
-          </a:lnRef>
-          <a:fillRef idx="3">
-            <a:schemeClr val="accent1"/>
-          </a:fillRef>
-          <a:effectRef idx="2">
-            <a:schemeClr val="accent1"/>
-          </a:effectRef>
-          <a:fontRef idx="minor">
-            <a:schemeClr val="lt1"/>
-          </a:fontRef>
-        </p:style>
-        <p:txBody>
-          <a:bodyPr wrap="square" rtlCol="0" anchor="ctr"/>
-          <a:lstStyle/>
-          <a:p>
-            <a:pPr algn="ctr">
-              <a:defRPr sz="1400" b="1">
-                <a:solidFill>
-                  <a:srgbClr val="E98F71"/>
-                </a:solidFill>
-                <a:latin typeface="Outfit"/>
-              </a:defRPr>
-            </a:pPr>
-            <a:r>
-              <a:t>RÚBRICA OFICIAL DE EVALUACIÓN (10 PTS)</a:t>
-            </a:r>
-          </a:p>
-          <a:p>
-            <a:pPr>
-              <a:defRPr sz="1300">
-                <a:solidFill>
-                  <a:srgbClr val="2F3A30"/>
-                </a:solidFill>
-                <a:latin typeface="Calibri"/>
-              </a:defRPr>
-            </a:pPr>
-            <a:r>
-              <a:t>• Cálculo de Ganancia Neta (3,5 pts):</a:t>
-            </a:r>
-            <a:br/>
-            <a:r>
-              <a:t>Identificación correcta del coste de oportunidad (pérdida de subsidio + transporte).</a:t>
-            </a:r>
-            <a:br/>
-            <a:br/>
-            <a:r>
-              <a:t>• Rigor Microeconómico wR (3,5 pts):</a:t>
-            </a:r>
-            <a:br/>
-            <a:r>
-              <a:t>Demostración analítica del umbral del Salario de Reserva (w &lt; wR) y trampa de la pobreza.</a:t>
-            </a:r>
-            <a:br/>
-            <a:br/>
-            <a:r>
-              <a:t>• Propuesta Técnica de Política (3,0 pts):</a:t>
-            </a:r>
-            <a:br/>
-            <a:r>
-              <a:t>Formulación de esquemas tipo EITC o compatibilidad gradual de rentas.</a:t>
-            </a:r>
-          </a:p>
-        </p:txBody>
-      </p:sp>
-    </p:spTree>
-  </p:cSld>
-  <p:clrMapOvr>
-    <a:masterClrMapping/>
-  </p:clrMapOvr>
-</p:sld>
-</file>
-
 <file path=ppt/slides/slide2.xml><?xml version="1.0" encoding="utf-8"?>
 <p:sld xmlns:a="http://schemas.openxmlformats.org/drawingml/2006/main" xmlns:r="http://schemas.openxmlformats.org/officeDocument/2006/relationships" xmlns:p="http://schemas.openxmlformats.org/presentationml/2006/main">
   <p:cSld>
@@ -8582,7 +8726,7 @@
         <p:spPr>
           <a:xfrm>
             <a:off x="8321040" y="1645920"/>
-            <a:ext cx="3291840" cy="4389120"/>
+            <a:ext cx="3291840" cy="1382415"/>
           </a:xfrm>
           <a:prstGeom prst="roundRect">
             <a:avLst/>
@@ -8621,6 +8765,7 @@
               </a:defRPr>
             </a:pPr>
             <a:r>
+              <a:rPr dirty="0"/>
               <a:t>ESCANEA PARA VOTAR</a:t>
             </a:r>
           </a:p>
@@ -8634,15 +8779,94 @@
               </a:defRPr>
             </a:pPr>
             <a:r>
-              <a:t>Acceso con cuenta UPO (@alu.upo.es)</a:t>
-            </a:r>
-            <a:br/>
-            <a:r>
-              <a:t>Votación en 30 segundos desde el móvil</a:t>
-            </a:r>
-          </a:p>
-        </p:txBody>
-      </p:sp>
+              <a:rPr dirty="0" err="1"/>
+              <a:t>Acceso</a:t>
+            </a:r>
+            <a:r>
+              <a:rPr dirty="0"/>
+              <a:t> con </a:t>
+            </a:r>
+            <a:r>
+              <a:rPr dirty="0" err="1"/>
+              <a:t>cuenta</a:t>
+            </a:r>
+            <a:r>
+              <a:rPr dirty="0"/>
+              <a:t> UPO (@alu.upo.es)</a:t>
+            </a:r>
+            <a:br>
+              <a:rPr dirty="0"/>
+            </a:br>
+            <a:r>
+              <a:rPr dirty="0" err="1"/>
+              <a:t>Votación</a:t>
+            </a:r>
+            <a:r>
+              <a:rPr dirty="0"/>
+              <a:t> </a:t>
+            </a:r>
+            <a:r>
+              <a:rPr dirty="0" err="1"/>
+              <a:t>en</a:t>
+            </a:r>
+            <a:r>
+              <a:rPr dirty="0"/>
+              <a:t> 30 </a:t>
+            </a:r>
+            <a:r>
+              <a:rPr dirty="0" err="1"/>
+              <a:t>segundos</a:t>
+            </a:r>
+            <a:r>
+              <a:rPr dirty="0"/>
+              <a:t> </a:t>
+            </a:r>
+            <a:r>
+              <a:rPr dirty="0" err="1"/>
+              <a:t>desde</a:t>
+            </a:r>
+            <a:r>
+              <a:rPr dirty="0"/>
+              <a:t> el </a:t>
+            </a:r>
+            <a:r>
+              <a:rPr dirty="0" err="1"/>
+              <a:t>móvil</a:t>
+            </a:r>
+            <a:endParaRPr dirty="0"/>
+          </a:p>
+        </p:txBody>
+      </p:sp>
+      <p:pic>
+        <p:nvPicPr>
+          <p:cNvPr id="10" name="Imagen 9" descr="Código QR">
+            <a:extLst>
+              <a:ext uri="{FF2B5EF4-FFF2-40B4-BE49-F238E27FC236}">
+                <a16:creationId xmlns:a16="http://schemas.microsoft.com/office/drawing/2014/main" id="{214FF9F6-C957-597E-A9F9-16E9F7350C23}"/>
+              </a:ext>
+            </a:extLst>
+          </p:cNvPr>
+          <p:cNvPicPr>
+            <a:picLocks noChangeAspect="1"/>
+          </p:cNvPicPr>
+          <p:nvPr/>
+        </p:nvPicPr>
+        <p:blipFill>
+          <a:blip r:embed="rId3"/>
+          <a:stretch>
+            <a:fillRect/>
+          </a:stretch>
+        </p:blipFill>
+        <p:spPr>
+          <a:xfrm>
+            <a:off x="8503182" y="3107485"/>
+            <a:ext cx="2927555" cy="2927555"/>
+          </a:xfrm>
+          <a:prstGeom prst="rect">
+            <a:avLst/>
+          </a:prstGeom>
+        </p:spPr>
+      </p:pic>
     </p:spTree>
   </p:cSld>
   <p:clrMapOvr>

</xml_diff>